<commit_message>
Turma dos participantes, prof. João Vitor e conferência do óleo
</commit_message>
<xml_diff>
--- a/apresentacao/Apresentacao_PI_QRCode_Lubrificantes.pptx
+++ b/apresentacao/Apresentacao_PI_QRCode_Lubrificantes.pptx
@@ -1141,7 +1141,7 @@
           <a:lstStyle/>
           <a:p>
             <a:r>
-              <a:t>Óleo novo: Ipiranga Ipitur HLP ISO 68 (70,9 cSt a 40 °C). As medições foram levadas à mesma temperatura pela curva do próprio óleo (equação de Walther, ASTM D341). Critério usual: até 10 % normal, 10 a 20 % atenção, acima de 20 % crítico. Suspeitas: fluido de corte, água (depósito alaranjado) ou reposição com óleo mais fino.</a:t>
+              <a:t>Ensaio feito no laboratório do SENAI com o auxílio do prof. João Vitor de Moura Barbosa. Óleo novo: Ipiranga Ipitur HLP ISO 68 (70,9 cSt a 40 °C na ficha; medido ≈ 66 cSt, dentro da faixa do VG 68). As medições foram levadas à mesma temperatura pela curva do próprio óleo (equação de Walther, ASTM D341). Critério usual: até 10 % normal, 10 a 20 % atenção, acima de 20 % crítico. Suspeitas: fluido de corte, água (depósito alaranjado) ou reposição com óleo mais fino.</a:t>
             </a:r>
           </a:p>
         </p:txBody>
@@ -5159,7 +5159,7 @@
                 </a:solidFill>
                 <a:latin typeface="Arial"/>
               </a:rPr>
-              <a:t>Óleo do torno Veker Eco/Diamant · viscosímetro rotacional Marte MVD-8</a:t>
+              <a:t>Ensaio de aprendizagem · viscosímetro Marte MVD-8 · prof. João Vitor de Moura Barbosa</a:t>
             </a:r>
           </a:p>
         </p:txBody>

</xml_diff>

<commit_message>
Tempo tradicional do Felipe corrigido (8:23,27): médias, tabelas, discussão, conclusão, resumo e slides
Co-Authored-By: Claude Opus 5.5 <noreply@anthropic.com>
</commit_message>
<xml_diff>
--- a/apresentacao/Apresentacao_PI_QRCode_Lubrificantes.pptx
+++ b/apresentacao/Apresentacao_PI_QRCode_Lubrificantes.pptx
@@ -187,7 +187,7 @@
                 <c:formatCode>General</c:formatCode>
                 <c:ptCount val="5"/>
                 <c:pt idx="0">
-                  <c:v>8.6</c:v>
+                  <c:v>8.4</c:v>
                 </c:pt>
                 <c:pt idx="1">
                   <c:v>10.7</c:v>
@@ -1001,7 +1001,7 @@
           <a:lstStyle/>
           <a:p>
             <a:r>
-              <a:t>Médias dos 5 participantes: tradicional 10:37 min, QR Code 2:58 min. Todos foram mais rápidos com o QR Code. Medido o tempo total (sem separar as etapas A, B e C).</a:t>
+              <a:t>Médias dos 5 participantes: tradicional 10:35 min, QR Code 2:58 min. Todos foram mais rápidos com o QR Code. Medido o tempo total (sem separar as etapas A, B e C).</a:t>
             </a:r>
           </a:p>
         </p:txBody>
@@ -4243,7 +4243,7 @@
                 </a:solidFill>
                 <a:latin typeface="Arial"/>
               </a:rPr>
-              <a:t>10:37 min</a:t>
+              <a:t>10:35 min</a:t>
             </a:r>
           </a:p>
           <a:p>
@@ -4608,7 +4608,7 @@
                 </a:solidFill>
                 <a:latin typeface="Impact"/>
               </a:rPr>
-              <a:t>7:39 min</a:t>
+              <a:t>7:37 min</a:t>
             </a:r>
           </a:p>
         </p:txBody>
@@ -4943,7 +4943,7 @@
                 </a:solidFill>
                 <a:latin typeface="Arial"/>
               </a:rPr>
-              <a:t>com 100 equipamentos. cerca de R$ 2.191 por ano, contra o custo baixo de etiqueta e impressão.</a:t>
+              <a:t>com 100 equipamentos. cerca de R$ 2.180 por ano, contra o custo baixo de etiqueta e impressão.</a:t>
             </a:r>
           </a:p>
         </p:txBody>

</xml_diff>

<commit_message>
Slide 10: prints novos do modelo 3D (vista explodida e corte com tampa em cruz, eixo vazado e etiqueta no lugar)
Co-Authored-By: Claude Opus 5.5 <noreply@anthropic.com>
</commit_message>
<xml_diff>
--- a/apresentacao/Apresentacao_PI_QRCode_Lubrificantes.pptx
+++ b/apresentacao/Apresentacao_PI_QRCode_Lubrificantes.pptx
@@ -3233,7 +3233,7 @@
       </p:sp>
       <p:pic>
         <p:nvPicPr>
-          <p:cNvPr id="14" name="Vista explodida" descr="image7.png"/>
+          <p:cNvPr id="14" name="Vista explodida" descr="3d-explodido.png"/>
           <p:cNvPicPr>
             <a:picLocks noChangeAspect="1"/>
           </p:cNvPicPr>
@@ -3247,8 +3247,8 @@
         </p:blipFill>
         <p:spPr>
           <a:xfrm>
-            <a:off x="548640" y="2103120"/>
-            <a:ext cx="4616138" cy="3611880"/>
+            <a:off x="548640" y="2057400"/>
+            <a:ext cx="4619254" cy="3749039"/>
           </a:xfrm>
           <a:prstGeom prst="rect">
             <a:avLst/>
@@ -3257,7 +3257,7 @@
       </p:pic>
       <p:pic>
         <p:nvPicPr>
-          <p:cNvPr id="15" name="Vista em corte" descr="image8.png"/>
+          <p:cNvPr id="15" name="Vista em corte" descr="3d-corte.png"/>
           <p:cNvPicPr>
             <a:picLocks noChangeAspect="1"/>
           </p:cNvPicPr>
@@ -3271,8 +3271,8 @@
         </p:blipFill>
         <p:spPr>
           <a:xfrm>
-            <a:off x="5532120" y="2103120"/>
-            <a:ext cx="3592524" cy="3611880"/>
+            <a:off x="5669280" y="2057400"/>
+            <a:ext cx="3725311" cy="3749039"/>
           </a:xfrm>
           <a:prstGeom prst="rect">
             <a:avLst/>

</xml_diff>

<commit_message>
Análise do óleo lançada pelo laboratório no SAP: TOR-001 sem formulário, doc 2.2.2 e slides 10/15
TOR-001 também só leitura (fonte sap) com documento IK11 simulado; cache v60. Documento: o
mecânico só coleta a amostra, o laboratório lança no SAP e a ficha puxa. Slide 15 com o novo
fluxo; slide 10 com a vista em corte mostrando o óleo no nível. PPTX regerado.

Co-Authored-By: Claude Opus 5.5 <noreply@anthropic.com>
</commit_message>
<xml_diff>
--- a/apresentacao/Apresentacao_PI_QRCode_Lubrificantes.pptx
+++ b/apresentacao/Apresentacao_PI_QRCode_Lubrificantes.pptx
@@ -861,7 +861,7 @@
           <a:lstStyle/>
           <a:p>
             <a:r>
-              <a:t>Tocando no número ou na peça, a ficha mostra nome, material, função, o que inspecionar e falhas comuns, além do tag (ex.: RED-001-COR-01). Peças internas são ilustrativas e devem ser confirmadas numa desmontagem.</a:t>
+              <a:t>Tocando no número ou na peça, a ficha mostra nome, material, função, o que inspecionar e falhas comuns, além do tag (ex.: RED-001-COR-01). Peças internas são ilustrativas e devem ser confirmadas numa desmontagem. Na vista em corte aparece o óleo no nível certo, até o bujão do meio (NIV-02): a rosca fica mergulhada e a coroa molha embaixo e leva o óleo para o engrenamento.</a:t>
             </a:r>
           </a:p>
         </p:txBody>
@@ -3272,7 +3272,7 @@
         <p:spPr>
           <a:xfrm>
             <a:off x="5669280" y="2057400"/>
-            <a:ext cx="3725311" cy="3749039"/>
+            <a:ext cx="3749039" cy="3749039"/>
           </a:xfrm>
           <a:prstGeom prst="rect">
             <a:avLst/>
@@ -5897,7 +5897,7 @@
                 </a:solidFill>
                 <a:latin typeface="Arial"/>
               </a:rPr>
-              <a:t>o QR mostra a situação do óleo com semáforo, o que fazer, as fotos do ensaio e o histórico. Quem medir de novo digita a viscosidade e a temperatura, e a ficha calcula a variação sozinha.</a:t>
+              <a:t>o QR mostra a situação do óleo com semáforo, o que fazer, as fotos do ensaio e o histórico. Quem lança o resultado é o laboratório, no SAP: a ficha puxa de lá e calcula a variação. O mecânico só consulta.</a:t>
             </a:r>
           </a:p>
           <a:p>

</xml_diff>

<commit_message>
Separa os projetos: Inspeção fica RED-001 e Lubrificação vira RED-002, no mesmo site
Cadastro próprio do RED-002, /l/RED-001 redireciona, registros do aparelho migram, novas etiquetas e
QR. Documento e slides atualizados. Cache v63.

Co-Authored-By: Claude Opus 5.5 <noreply@anthropic.com>
</commit_message>
<xml_diff>
--- a/apresentacao/Apresentacao_PI_QRCode_Lubrificantes.pptx
+++ b/apresentacao/Apresentacao_PI_QRCode_Lubrificantes.pptx
@@ -861,7 +861,7 @@
           <a:lstStyle/>
           <a:p>
             <a:r>
-              <a:t>Tocando no número ou na peça, a ficha mostra nome, material, função, o que inspecionar e falhas comuns, além do tag (ex.: RED-001-COR-01). Peças internas são ilustrativas e devem ser confirmadas numa desmontagem. Na vista em corte aparece o óleo no nível certo, até o bujão do meio (NIV-02): a rosca fica mergulhada e a coroa molha embaixo e leva o óleo para o engrenamento.</a:t>
+              <a:t>Tocando no número ou na peça, a ficha mostra nome, material, função, o que inspecionar e falhas comuns, além do tag (ex.: RED-002-COR-01). Peças internas são ilustrativas e devem ser confirmadas numa desmontagem. Na vista em corte aparece o óleo no nível certo, até o bujão do meio (NIV-02): a rosca fica mergulhada e a coroa molha embaixo e leva o óleo para o engrenamento.</a:t>
             </a:r>
           </a:p>
         </p:txBody>
@@ -1981,7 +1981,7 @@
           <a:lstStyle/>
           <a:p>
             <a:r>
-              <a:t>Troca simulada em 14/10/2026: próxima troca prevista para 30/06/2028. Tag do óleo RED-001-OLE-04, galão laranja (código e cor fictícios, de exemplo). A integração com o SAP é só uma proposta mostrada na tela.</a:t>
+              <a:t>Troca simulada em 14/10/2026: próxima troca prevista para 30/06/2028. Tag do óleo RED-002-OLE-04, galão laranja (código e cor fictícios, de exemplo). A integração com o SAP é só uma proposta mostrada na tela.</a:t>
             </a:r>
           </a:p>
         </p:txBody>
@@ -5913,7 +5913,7 @@
                 </a:solidFill>
                 <a:latin typeface="Arial"/>
               </a:rPr>
-              <a:t>RED-001 (redutor): </a:t>
+              <a:t>RED-002 (redutor): </a:t>
             </a:r>
             <a:r>
               <a:rPr sz="1600" b="0" i="0">
@@ -7662,7 +7662,7 @@
       </p:sp>
       <p:pic>
         <p:nvPicPr>
-          <p:cNvPr id="8" name="Picture 7" descr="qr-lubrificacao-RED-001.png"/>
+          <p:cNvPr id="8" name="Picture 7" descr="qr-lubrificacao-RED-002.png"/>
           <p:cNvPicPr>
             <a:picLocks noChangeAspect="1"/>
           </p:cNvPicPr>
@@ -7718,7 +7718,7 @@
                 </a:solidFill>
                 <a:latin typeface="Arial"/>
               </a:rPr>
-              <a:t>RED-001</a:t>
+              <a:t>RED-002</a:t>
             </a:r>
           </a:p>
         </p:txBody>
@@ -11981,7 +11981,7 @@
       </p:sp>
       <p:pic>
         <p:nvPicPr>
-          <p:cNvPr id="14" name="QR RED-001" descr="qr-lubrificacao-RED-001.png"/>
+          <p:cNvPr id="14" name="QR RED-002" descr="qr-lubrificacao-RED-002.png"/>
           <p:cNvPicPr>
             <a:picLocks noChangeAspect="1"/>
           </p:cNvPicPr>
@@ -12053,7 +12053,7 @@
                 </a:solidFill>
                 <a:latin typeface="Arial"/>
               </a:rPr>
-              <a:t>.vercel.app/l/RED-001</a:t>
+              <a:t>.vercel.app/l/RED-002</a:t>
             </a:r>
           </a:p>
         </p:txBody>

</xml_diff>